<commit_message>
pptx: count charts from graphicData uses, not the bare namespace string
Real-deck QA (a Google Slides export with zero images) hit the ambiguous
prompt: producers declare xmlns:c=...drawingml/2006/chart on EVERY slide
whether or not a chart exists, and the counter matched the bare string.
Charts now count only from actual <a:graphicData uri=...chart> uses.

Verified against the QA deck (now convert, images 0). Fixture slides now
carry the chart namespace declaration like real producers, plus a direct
regression test that a declaration alone is not a visual.

Co-Authored-By: Claude Fable 5 <noreply@anthropic.com>
</commit_message>
<xml_diff>
--- a/test/fixtures/tiny.pptx
+++ b/test/fixtures/tiny.pptx
@@ -4,7 +4,7 @@
 </file>
 
 <file path=ppt/slides/slide1.xml><?xml version="1.0" encoding="utf-8"?>
-<p:sld xmlns:p="http://schemas.openxmlformats.org/presentationml/2006/main" xmlns:a="http://schemas.openxmlformats.org/drawingml/2006/main" xmlns:r="http://schemas.openxmlformats.org/officeDocument/2006/relationships">
+<p:sld xmlns:p="http://schemas.openxmlformats.org/presentationml/2006/main" xmlns:a="http://schemas.openxmlformats.org/drawingml/2006/main" xmlns:r="http://schemas.openxmlformats.org/officeDocument/2006/relationships" xmlns:c="http://schemas.openxmlformats.org/drawingml/2006/chart">
   <p:cSld>
     <p:spTree>
       <p:sp>
@@ -55,7 +55,7 @@
 </file>
 
 <file path=ppt/slides/slide2.xml><?xml version="1.0" encoding="utf-8"?>
-<p:sld xmlns:p="http://schemas.openxmlformats.org/presentationml/2006/main" xmlns:a="http://schemas.openxmlformats.org/drawingml/2006/main" xmlns:r="http://schemas.openxmlformats.org/officeDocument/2006/relationships">
+<p:sld xmlns:p="http://schemas.openxmlformats.org/presentationml/2006/main" xmlns:a="http://schemas.openxmlformats.org/drawingml/2006/main" xmlns:r="http://schemas.openxmlformats.org/officeDocument/2006/relationships" xmlns:c="http://schemas.openxmlformats.org/drawingml/2006/chart">
   <p:cSld>
     <p:spTree>
       <p:sp>

</xml_diff>